<commit_message>
.\Python\Lesson 11 - Testing"
</commit_message>
<xml_diff>
--- a/Cloud/Lesson 04 - Intro to Containers/Containers and Images.pptx
+++ b/Cloud/Lesson 04 - Intro to Containers/Containers and Images.pptx
@@ -224,7 +224,7 @@
           <a:p>
             <a:fld id="{7D2F5B96-EC90-4B10-91AC-E32DA21E81E1}" type="datetimeFigureOut">
               <a:rPr lang="en-US" smtClean="0"/>
-              <a:t>6/9/2026</a:t>
+              <a:t>8/5/2026</a:t>
             </a:fld>
             <a:endParaRPr lang="en-US"/>
           </a:p>
@@ -491,6 +491,93 @@
 </p:notesMaster>
 </file>
 
+<file path=ppt/notesSlides/notesSlide1.xml><?xml version="1.0" encoding="utf-8"?>
+<p:notes xmlns:a="http://schemas.openxmlformats.org/drawingml/2006/main" xmlns:r="http://schemas.openxmlformats.org/officeDocument/2006/relationships" xmlns:p="http://schemas.openxmlformats.org/presentationml/2006/main">
+  <p:cSld>
+    <p:spTree>
+      <p:nvGrpSpPr>
+        <p:cNvPr id="1" name=""/>
+        <p:cNvGrpSpPr/>
+        <p:nvPr/>
+      </p:nvGrpSpPr>
+      <p:grpSpPr>
+        <a:xfrm>
+          <a:off x="0" y="0"/>
+          <a:ext cx="0" cy="0"/>
+          <a:chOff x="0" y="0"/>
+          <a:chExt cx="0" cy="0"/>
+        </a:xfrm>
+      </p:grpSpPr>
+      <p:sp>
+        <p:nvSpPr>
+          <p:cNvPr id="2" name="Slide Image Placeholder 1"/>
+          <p:cNvSpPr>
+            <a:spLocks noGrp="1" noRot="1" noChangeAspect="1"/>
+          </p:cNvSpPr>
+          <p:nvPr>
+            <p:ph type="sldImg"/>
+          </p:nvPr>
+        </p:nvSpPr>
+        <p:spPr/>
+      </p:sp>
+      <p:sp>
+        <p:nvSpPr>
+          <p:cNvPr id="3" name="Notes Placeholder 2"/>
+          <p:cNvSpPr>
+            <a:spLocks noGrp="1"/>
+          </p:cNvSpPr>
+          <p:nvPr>
+            <p:ph type="body" idx="1"/>
+          </p:nvPr>
+        </p:nvSpPr>
+        <p:spPr/>
+        <p:txBody>
+          <a:bodyPr/>
+          <a:lstStyle/>
+          <a:p>
+            <a:endParaRPr lang="en-US" dirty="0"/>
+          </a:p>
+          <a:p>
+            <a:endParaRPr lang="en-US" dirty="0"/>
+          </a:p>
+        </p:txBody>
+      </p:sp>
+      <p:sp>
+        <p:nvSpPr>
+          <p:cNvPr id="4" name="Slide Number Placeholder 3"/>
+          <p:cNvSpPr>
+            <a:spLocks noGrp="1"/>
+          </p:cNvSpPr>
+          <p:nvPr>
+            <p:ph type="sldNum" sz="quarter" idx="5"/>
+          </p:nvPr>
+        </p:nvSpPr>
+        <p:spPr/>
+        <p:txBody>
+          <a:bodyPr/>
+          <a:lstStyle/>
+          <a:p>
+            <a:fld id="{BE457D5F-ED05-449E-97D0-205DAB987247}" type="slidenum">
+              <a:rPr lang="en-US" smtClean="0"/>
+              <a:t>18</a:t>
+            </a:fld>
+            <a:endParaRPr lang="en-US"/>
+          </a:p>
+        </p:txBody>
+      </p:sp>
+    </p:spTree>
+    <p:extLst>
+      <p:ext uri="{BB962C8B-B14F-4D97-AF65-F5344CB8AC3E}">
+        <p14:creationId xmlns:p14="http://schemas.microsoft.com/office/powerpoint/2010/main" val="477688686"/>
+      </p:ext>
+    </p:extLst>
+  </p:cSld>
+  <p:clrMapOvr>
+    <a:masterClrMapping/>
+  </p:clrMapOvr>
+</p:notes>
+</file>
+
 <file path=ppt/slideLayouts/slideLayout1.xml><?xml version="1.0" encoding="utf-8"?>
 <p:sldLayout xmlns:a="http://schemas.openxmlformats.org/drawingml/2006/main" xmlns:r="http://schemas.openxmlformats.org/officeDocument/2006/relationships" xmlns:p="http://schemas.openxmlformats.org/presentationml/2006/main" showMasterSp="0" preserve="1" userDrawn="1">
   <p:cSld name="Title Slide">
@@ -539,7 +626,7 @@
           <a:p>
             <a:fld id="{7A3E0868-4E26-4CDC-8A56-D70E2D8B12FE}" type="datetime3">
               <a:rPr lang="en-US" smtClean="0"/>
-              <a:t>9 June 2026</a:t>
+              <a:t>5 August 2026</a:t>
             </a:fld>
             <a:endParaRPr lang="en-US"/>
           </a:p>
@@ -3100,7 +3187,7 @@
           <a:p>
             <a:fld id="{A7B8021B-6105-4216-96FC-94348F216D0E}" type="datetime3">
               <a:rPr lang="en-US" smtClean="0"/>
-              <a:t>9 June 2026</a:t>
+              <a:t>5 August 2026</a:t>
             </a:fld>
             <a:endParaRPr lang="en-US"/>
           </a:p>
@@ -4797,7 +4884,7 @@
           <a:p>
             <a:fld id="{5D27CFAB-73E6-44A8-B862-B3306344E3F2}" type="datetime3">
               <a:rPr lang="en-US" smtClean="0"/>
-              <a:t>9 June 2026</a:t>
+              <a:t>5 August 2026</a:t>
             </a:fld>
             <a:endParaRPr lang="en-US"/>
           </a:p>
@@ -6587,7 +6674,7 @@
           <a:p>
             <a:fld id="{A9B2E784-A5F5-4301-881B-94AC8DBF9DED}" type="datetime3">
               <a:rPr lang="en-US" smtClean="0"/>
-              <a:t>9 June 2026</a:t>
+              <a:t>5 August 2026</a:t>
             </a:fld>
             <a:endParaRPr lang="en-US"/>
           </a:p>
@@ -6766,7 +6853,7 @@
           <a:p>
             <a:fld id="{18EAB3A5-9E92-4BB9-8F22-9632B4FBEDBA}" type="datetime3">
               <a:rPr lang="en-US" smtClean="0"/>
-              <a:t>9 June 2026</a:t>
+              <a:t>5 August 2026</a:t>
             </a:fld>
             <a:endParaRPr lang="en-US"/>
           </a:p>
@@ -6993,7 +7080,7 @@
           <a:p>
             <a:fld id="{40923810-5FB2-48C9-96CA-1DE2C4773142}" type="datetime3">
               <a:rPr lang="en-US" smtClean="0"/>
-              <a:t>9 June 2026</a:t>
+              <a:t>5 August 2026</a:t>
             </a:fld>
             <a:endParaRPr lang="en-US"/>
           </a:p>
@@ -7283,7 +7370,7 @@
           <a:p>
             <a:fld id="{E50EFF4B-86EB-42FB-93EA-7D8F9CB2466F}" type="datetime3">
               <a:rPr lang="en-US" smtClean="0"/>
-              <a:t>9 June 2026</a:t>
+              <a:t>5 August 2026</a:t>
             </a:fld>
             <a:endParaRPr lang="en-US"/>
           </a:p>
@@ -7895,7 +7982,7 @@
           <a:p>
             <a:fld id="{FB14FC24-E041-45E9-9A72-E5755A86890F}" type="datetime3">
               <a:rPr lang="en-US" smtClean="0"/>
-              <a:t>9 June 2026</a:t>
+              <a:t>5 August 2026</a:t>
             </a:fld>
             <a:endParaRPr lang="en-US"/>
           </a:p>
@@ -8755,7 +8842,7 @@
           <a:p>
             <a:fld id="{98A19125-94A7-4474-858C-FD9C4ABE9DDA}" type="datetime3">
               <a:rPr lang="en-US" smtClean="0"/>
-              <a:t>9 June 2026</a:t>
+              <a:t>5 August 2026</a:t>
             </a:fld>
             <a:endParaRPr lang="en-US"/>
           </a:p>
@@ -9858,7 +9945,7 @@
           <a:p>
             <a:fld id="{3BA0343D-C8D8-43CE-BB79-50DEA219DB07}" type="datetime3">
               <a:rPr lang="en-US" smtClean="0"/>
-              <a:t>9 June 2026</a:t>
+              <a:t>5 August 2026</a:t>
             </a:fld>
             <a:endParaRPr lang="en-US"/>
           </a:p>
@@ -10147,7 +10234,7 @@
           <a:p>
             <a:fld id="{453BD212-0B9F-4987-965F-AC83B2FC354F}" type="datetime3">
               <a:rPr lang="en-US" smtClean="0"/>
-              <a:t>9 June 2026</a:t>
+              <a:t>5 August 2026</a:t>
             </a:fld>
             <a:endParaRPr lang="en-US"/>
           </a:p>
@@ -10392,7 +10479,7 @@
           <a:p>
             <a:fld id="{6DDC931E-8CBE-4A3F-A034-9B6122C6DCDB}" type="datetime3">
               <a:rPr lang="en-US" smtClean="0"/>
-              <a:t>9 June 2026</a:t>
+              <a:t>5 August 2026</a:t>
             </a:fld>
             <a:endParaRPr lang="en-US"/>
           </a:p>
@@ -12158,7 +12245,7 @@
           <a:p>
             <a:fld id="{220AF9C2-5E8A-4308-AE6B-CA9B65007D0E}" type="datetime3">
               <a:rPr lang="en-US" smtClean="0"/>
-              <a:t>9 June 2026</a:t>
+              <a:t>5 August 2026</a:t>
             </a:fld>
             <a:endParaRPr lang="en-US"/>
           </a:p>
@@ -12471,7 +12558,7 @@
           <a:p>
             <a:fld id="{FF31E861-D2AF-431D-860B-DCF67C218052}" type="datetime3">
               <a:rPr lang="en-US" smtClean="0"/>
-              <a:t>9 June 2026</a:t>
+              <a:t>5 August 2026</a:t>
             </a:fld>
             <a:endParaRPr lang="en-US"/>
           </a:p>
@@ -12750,7 +12837,7 @@
           <a:p>
             <a:fld id="{D1DA25B2-AAF1-4C1F-AA38-12D5BFA7D4C8}" type="datetime3">
               <a:rPr lang="en-US" smtClean="0"/>
-              <a:t>9 June 2026</a:t>
+              <a:t>5 August 2026</a:t>
             </a:fld>
             <a:endParaRPr lang="en-US"/>
           </a:p>
@@ -13029,7 +13116,7 @@
           <a:p>
             <a:fld id="{A25C0F39-45D0-48E9-90B3-7FE8FCE561C8}" type="datetime3">
               <a:rPr lang="en-US" smtClean="0"/>
-              <a:t>9 June 2026</a:t>
+              <a:t>5 August 2026</a:t>
             </a:fld>
             <a:endParaRPr lang="en-US"/>
           </a:p>
@@ -13530,7 +13617,7 @@
           <a:p>
             <a:fld id="{9BAF1A3D-92FA-4F24-9781-74AFA516A230}" type="datetime3">
               <a:rPr lang="en-US" smtClean="0"/>
-              <a:t>9 June 2026</a:t>
+              <a:t>5 August 2026</a:t>
             </a:fld>
             <a:endParaRPr lang="en-US"/>
           </a:p>
@@ -13657,7 +13744,7 @@
           <a:p>
             <a:fld id="{5719C672-856D-4617-A693-8FE15749A9B7}" type="datetime3">
               <a:rPr lang="en-US" smtClean="0"/>
-              <a:t>9 June 2026</a:t>
+              <a:t>5 August 2026</a:t>
             </a:fld>
             <a:endParaRPr lang="en-US"/>
           </a:p>
@@ -13792,7 +13879,7 @@
           <a:p>
             <a:fld id="{5F6C764D-A39E-4C03-B161-E0BC66E8883B}" type="datetime3">
               <a:rPr lang="en-US" smtClean="0"/>
-              <a:t>9 June 2026</a:t>
+              <a:t>5 August 2026</a:t>
             </a:fld>
             <a:endParaRPr lang="en-US"/>
           </a:p>
@@ -14034,7 +14121,7 @@
           <a:p>
             <a:fld id="{6E3E33F9-20B7-4995-BE7D-165DBB597850}" type="datetime3">
               <a:rPr lang="en-US" smtClean="0"/>
-              <a:t>9 June 2026</a:t>
+              <a:t>5 August 2026</a:t>
             </a:fld>
             <a:endParaRPr lang="en-US"/>
           </a:p>
@@ -14147,7 +14234,7 @@
           <a:p>
             <a:fld id="{CD41C263-3501-4369-A962-62B6BF915CDE}" type="datetime3">
               <a:rPr lang="en-US" smtClean="0"/>
-              <a:t>9 June 2026</a:t>
+              <a:t>5 August 2026</a:t>
             </a:fld>
             <a:endParaRPr lang="en-US"/>
           </a:p>
@@ -14550,7 +14637,7 @@
           <a:p>
             <a:fld id="{B06F3EBE-B2E8-4992-9F00-9E4B44F057C0}" type="datetime3">
               <a:rPr lang="en-US" smtClean="0"/>
-              <a:t>9 June 2026</a:t>
+              <a:t>5 August 2026</a:t>
             </a:fld>
             <a:endParaRPr lang="en-US"/>
           </a:p>
@@ -14682,7 +14769,7 @@
           <a:p>
             <a:fld id="{D41656AB-D2E1-472E-8B95-0DF5C6E1D623}" type="datetime3">
               <a:rPr lang="en-US" smtClean="0"/>
-              <a:t>9 June 2026</a:t>
+              <a:t>5 August 2026</a:t>
             </a:fld>
             <a:endParaRPr lang="en-US"/>
           </a:p>
@@ -18878,7 +18965,7 @@
           <a:p>
             <a:fld id="{AD3160A9-B1E4-4AE8-B854-46ED2C2068C2}" type="datetimeFigureOut">
               <a:rPr lang="en-US" smtClean="0"/>
-              <a:t>6/9/2026</a:t>
+              <a:t>8/5/2026</a:t>
             </a:fld>
             <a:endParaRPr lang="en-US"/>
           </a:p>
@@ -19143,7 +19230,7 @@
           <a:p>
             <a:fld id="{AD3160A9-B1E4-4AE8-B854-46ED2C2068C2}" type="datetimeFigureOut">
               <a:rPr lang="en-US" smtClean="0"/>
-              <a:t>6/9/2026</a:t>
+              <a:t>8/5/2026</a:t>
             </a:fld>
             <a:endParaRPr lang="en-US"/>
           </a:p>
@@ -19555,7 +19642,7 @@
           <a:p>
             <a:fld id="{AD3160A9-B1E4-4AE8-B854-46ED2C2068C2}" type="datetimeFigureOut">
               <a:rPr lang="en-US" smtClean="0"/>
-              <a:t>6/9/2026</a:t>
+              <a:t>8/5/2026</a:t>
             </a:fld>
             <a:endParaRPr lang="en-US"/>
           </a:p>
@@ -19843,7 +19930,7 @@
           <a:p>
             <a:fld id="{AD3160A9-B1E4-4AE8-B854-46ED2C2068C2}" type="datetimeFigureOut">
               <a:rPr lang="en-US" smtClean="0"/>
-              <a:t>6/9/2026</a:t>
+              <a:t>8/5/2026</a:t>
             </a:fld>
             <a:endParaRPr lang="en-US"/>
           </a:p>
@@ -20039,7 +20126,7 @@
           <a:p>
             <a:fld id="{AD622D1A-DF83-41A8-85FF-04D90BF831D3}" type="datetime3">
               <a:rPr lang="en-US" smtClean="0"/>
-              <a:t>9 June 2026</a:t>
+              <a:t>5 August 2026</a:t>
             </a:fld>
             <a:endParaRPr lang="en-US"/>
           </a:p>
@@ -20289,7 +20376,7 @@
           <a:p>
             <a:fld id="{334F72C3-CDF3-44A8-B602-1649B1728485}" type="datetime3">
               <a:rPr lang="en-US" smtClean="0"/>
-              <a:t>9 June 2026</a:t>
+              <a:t>5 August 2026</a:t>
             </a:fld>
             <a:endParaRPr lang="en-US"/>
           </a:p>
@@ -20596,7 +20683,7 @@
           <a:p>
             <a:fld id="{1E0132BA-B5E7-4FFD-AF6C-169169D47D4A}" type="datetime3">
               <a:rPr lang="en-US" smtClean="0"/>
-              <a:t>9 June 2026</a:t>
+              <a:t>5 August 2026</a:t>
             </a:fld>
             <a:endParaRPr lang="en-US"/>
           </a:p>
@@ -21077,7 +21164,7 @@
           <a:p>
             <a:fld id="{81A30091-1C2A-4151-8D3C-D1E47A72615F}" type="datetime3">
               <a:rPr lang="en-US" smtClean="0"/>
-              <a:t>9 June 2026</a:t>
+              <a:t>5 August 2026</a:t>
             </a:fld>
             <a:endParaRPr lang="en-US"/>
           </a:p>
@@ -21714,7 +21801,7 @@
           <a:p>
             <a:fld id="{35D703CE-07B4-4C05-A488-B4566700621F}" type="datetime3">
               <a:rPr lang="en-US" smtClean="0"/>
-              <a:t>9 June 2026</a:t>
+              <a:t>5 August 2026</a:t>
             </a:fld>
             <a:endParaRPr lang="en-US"/>
           </a:p>
@@ -22772,7 +22859,7 @@
           <a:p>
             <a:fld id="{694BD61C-20BA-43AF-A21F-1DAFB3200099}" type="datetime3">
               <a:rPr lang="en-US" smtClean="0"/>
-              <a:t>9 June 2026</a:t>
+              <a:t>5 August 2026</a:t>
             </a:fld>
             <a:endParaRPr lang="en-US"/>
           </a:p>
@@ -23259,7 +23346,7 @@
           <a:p>
             <a:fld id="{CABCB1B0-B6E5-4DD1-BB55-95C076D6C0C8}" type="datetime3">
               <a:rPr lang="en-US" smtClean="0"/>
-              <a:t>9 June 2026</a:t>
+              <a:t>5 August 2026</a:t>
             </a:fld>
             <a:endParaRPr lang="en-US"/>
           </a:p>
@@ -23809,7 +23896,7 @@
             <a:fld id="{7A3E0868-4E26-4CDC-8A56-D70E2D8B12FE}" type="datetime3">
               <a:rPr lang="en-US" smtClean="0"/>
               <a:pPr/>
-              <a:t>9 June 2026</a:t>
+              <a:t>5 August 2026</a:t>
             </a:fld>
             <a:endParaRPr lang="en-US" dirty="0"/>
           </a:p>

</xml_diff>